<commit_message>
Apply the critic's red-team: ledger counts, claim scope, test-set wording, review labels, Frontier seeds
A1 ledger 21 rows (16 independent reviewer or validator, 2 mixed, 3 author-only; facts and trace read the
explicit per-row classes). A2 no advantage shown in two small comparisons, the pilot at a ceiling. A3 answers
come from stated methods under declared conventions. A5 scorecard revised after a Codex review of the first
draft, revision not re-reviewed. A6 Frontier is a proposal and our own seeds failed our own validator (R21).
B1-B5: by-construction note, no wet-lab experiment, implementation-agreement caveat, headroom reading,
metadata-and-wording check. A4 answered with a reason in sources.md.

Co-Authored-By: Claude Sonnet 5.5 <noreply@anthropic.com>
</commit_message>
<xml_diff>
--- a/presentation/delphi/deck.pptx
+++ b/presentation/delphi/deck.pptx
@@ -507,7 +507,7 @@
           <a:lstStyle/>
           <a:p>
             <a:r>
-              <a:t>The textbook inequality is green. On a tissue of length pi, no admissible mode is in the band; at two pi, one is. This is a linear statement for a declared model, classical mathematics. What is new is only that a program checks it, with a witness, before a law is applied. We ran no experiment.</a:t>
+              <a:t>The textbook inequality is green. On a tissue of length pi, no admissible mode is in the band; at two pi, one is. This is a linear statement for a declared model, classical mathematics. What is new is only that a program checks it, with a witness, before a law is applied. No wet-lab experiment; simulations only.</a:t>
             </a:r>
           </a:p>
         </p:txBody>
@@ -647,7 +647,7 @@
           <a:lstStyle/>
           <a:p>
             <a:r>
-              <a:t>The Price identity is already in ATLAS, so ours is a duplicate. We add a compiled conditional Hamilton regression theorem with witnesses. The test set is frozen: one hundred twenty-seven requests with exact answers. On the fifty Turing and wavelength items the gate agrees with the key on all fifty, the plain formula on twenty-nine. Trap-enriched, our own conventions: not external validation.</a:t>
+              <a:t>The Price identity is already in ATLAS, so ours is a duplicate. We add a compiled conditional Hamilton regression theorem with witnesses. The test set is frozen: one hundred twenty-seven requests, answers from stated methods under declared conventions. On the fifty Turing and wavelength items the gate agrees with the key on all fifty, the plain formula on twenty-nine. Our own conventions: not external validation.</a:t>
             </a:r>
           </a:p>
         </p:txBody>
@@ -717,7 +717,7 @@
           <a:lstStyle/>
           <a:p>
             <a:r>
-              <a:t>The ledger. Five claims we held that did not survive, each with a witness: a diffusion threshold of ten, false at ratio one point one; our own liquid bridge key; a regression that tested a different question; benchmark ids that leaked labels; our Price node, already in ATLAS. Seventeen of twenty rows were caught by an independent reviewer or a measurement, three by the author. No control arm: audit versus self-audit, not collective intelligence.</a:t>
+              <a:t>The ledger. Five claims we held that did not survive, each with a witness: a diffusion threshold of ten, false at ratio one point one; our liquid bridge key; a regression that tested a different question; ids that leaked labels; our Price node, already in ATLAS. Sixteen of twenty-one rows were caught by an independent reviewer or validator, two with a hold, three only by the author. No control arm: not collective intelligence.</a:t>
             </a:r>
           </a:p>
         </p:txBody>
@@ -787,7 +787,7 @@
           <a:lstStyle/>
           <a:p>
             <a:r>
-              <a:t>What the collective measured. Shared specialists equal a single planner, seventy-eight of a hundred each; a plain lazy search reaches ninety-six. On the frozen test set, unguarded models without a code tool score one hundred twenty-one and one hundred ten of one hundred twenty-seven; the checker-tool arm was not run. In the nineteen-lemma proof pilot every arm certified all nineteen, a ceiling, and library reuse saved no calls or tokens. More agents did not help.</a:t>
+              <a:t>What the collective measured. Shared specialists equal a single planner, seventy-eight of a hundred each; a plain lazy search reaches ninety-six, mostly in one pair. No advantage shown in two small comparisons. Unguarded models without a code tool score one hundred twenty-one and one hundred ten of one hundred twenty-seven; the checker arm was not run. The proof pilot sat at a ceiling.</a:t>
             </a:r>
           </a:p>
         </p:txBody>
@@ -857,7 +857,7 @@
           <a:lstStyle/>
           <a:p>
             <a:r>
-              <a:t>Reusable now: a checker that returns a witness. Outside use: none observed yet. Next, a proposal: a pilot on a modelling team's reuse decisions, and Delphi Frontier, one page per open problem. Scorecard: of twenty-one records, six linked to benchmark families, one related lemma, two empirical, twelve without a check. Credit ATLAS and Prove2Me. Make the assumptions behind a model decision executable and auditable.</a:t>
+              <a:t>Reusable now: a checker that returns a witness. Outside use: none observed yet. Next, a proposal: a pilot on a modelling team's reuse decisions, and Delphi Frontier; our own seed questions failed our own validator, zero of seven bounded. Scorecard: twenty-one records, six linked to benchmark families, one related lemma, two empirical, twelve without a check; single reader. Credit ATLAS and Prove2Me. Make the assumptions executable and auditable.</a:t>
             </a:r>
           </a:p>
         </p:txBody>

</xml_diff>